<commit_message>
Add slides listing Ivy League and Red Brick member universities
Co-Authored-By: Claude Sonnet 5.5 <noreply@anthropic.com>
Claude-Session: https://claude.ai/code/session_01DLyNyTQnbdkdmfku5csQUZ
</commit_message>
<xml_diff>
--- a/out/Prestigious_Universities.pptx
+++ b/out/Prestigious_Universities.pptx
@@ -10,9 +10,11 @@
   <p:sldIdLst>
     <p:sldId id="299" r:id="rId2"/>
     <p:sldId id="309" r:id="rId38"/>
+    <p:sldId id="312" r:id="rId41"/>
     <p:sldId id="279" r:id="rId22"/>
     <p:sldId id="276" r:id="rId20"/>
     <p:sldId id="310" r:id="rId39"/>
+    <p:sldId id="313" r:id="rId42"/>
     <p:sldId id="307" r:id="rId36"/>
     <p:sldId id="308" r:id="rId37"/>
     <p:sldId id="263" r:id="rId19"/>
@@ -26104,6 +26106,248 @@
             <a:r>
               <a:rPr lang="en-US" dirty="0"/>
               <a:t>Anton Lerer, group КФ26-3</a:t>
+            </a:r>
+          </a:p>
+        </p:txBody>
+      </p:sp>
+    </p:spTree>
+  </p:cSld>
+  <p:clrMapOvr>
+    <a:masterClrMapping/>
+  </p:clrMapOvr>
+</p:sld>
+</file>
+
+<file path=ppt/slides/slide35.xml><?xml version="1.0" encoding="utf-8"?>
+<p:sld xmlns:a="http://schemas.openxmlformats.org/drawingml/2006/main" xmlns:r="http://schemas.openxmlformats.org/officeDocument/2006/relationships" xmlns:p="http://schemas.openxmlformats.org/presentationml/2006/main">
+  <p:cSld>
+    <p:spTree>
+      <p:nvGrpSpPr>
+        <p:cNvPr id="1" name=""/>
+        <p:cNvGrpSpPr/>
+        <p:nvPr/>
+      </p:nvGrpSpPr>
+      <p:grpSpPr>
+        <a:xfrm>
+          <a:off x="0" y="0"/>
+          <a:ext cx="0" cy="0"/>
+          <a:chOff x="0" y="0"/>
+          <a:chExt cx="0" cy="0"/>
+        </a:xfrm>
+      </p:grpSpPr>
+      <p:sp>
+        <p:nvSpPr>
+          <p:cNvPr id="2" name="Text 2"/>
+          <p:cNvSpPr>
+            <a:spLocks noGrp="1"/>
+          </p:cNvSpPr>
+          <p:nvPr>
+            <p:ph type="body" sz="quarter" idx="21"/>
+          </p:nvPr>
+        </p:nvSpPr>
+        <p:spPr/>
+        <p:txBody>
+          <a:bodyPr/>
+          <a:lstStyle/>
+          <a:p>
+            <a:r>
+              <a:rPr lang="en-US" dirty="0"/>
+              <a:t>Ivy League members</a:t>
+            </a:r>
+          </a:p>
+        </p:txBody>
+      </p:sp>
+      <p:sp>
+        <p:nvSpPr>
+          <p:cNvPr id="3" name="Text 3"/>
+          <p:cNvSpPr>
+            <a:spLocks noGrp="1"/>
+          </p:cNvSpPr>
+          <p:nvPr>
+            <p:ph type="body" sz="quarter" idx="22"/>
+          </p:nvPr>
+        </p:nvSpPr>
+        <p:spPr/>
+        <p:txBody>
+          <a:bodyPr/>
+          <a:lstStyle/>
+          <a:p>
+            <a:r>
+              <a:rPr lang="en-US" sz="2800" dirty="0"/>
+              <a:t>Brown</a:t>
+            </a:r>
+          </a:p>
+          <a:p>
+            <a:r>
+              <a:rPr lang="en-US" sz="2800" dirty="0"/>
+              <a:t>Columbia</a:t>
+            </a:r>
+          </a:p>
+          <a:p>
+            <a:r>
+              <a:rPr lang="en-US" sz="2800" dirty="0"/>
+              <a:t>Cornell</a:t>
+            </a:r>
+          </a:p>
+          <a:p>
+            <a:r>
+              <a:rPr lang="en-US" sz="2800" dirty="0"/>
+              <a:t>Dartmouth</a:t>
+            </a:r>
+          </a:p>
+        </p:txBody>
+      </p:sp>
+      <p:sp>
+        <p:nvSpPr>
+          <p:cNvPr id="4" name="Text 4"/>
+          <p:cNvSpPr>
+            <a:spLocks noGrp="1"/>
+          </p:cNvSpPr>
+          <p:nvPr>
+            <p:ph type="body" sz="quarter" idx="25"/>
+          </p:nvPr>
+        </p:nvSpPr>
+        <p:spPr/>
+        <p:txBody>
+          <a:bodyPr/>
+          <a:lstStyle/>
+          <a:p>
+            <a:r>
+              <a:rPr lang="en-US" sz="2800" dirty="0"/>
+              <a:t>Harvard</a:t>
+            </a:r>
+          </a:p>
+          <a:p>
+            <a:r>
+              <a:rPr lang="en-US" sz="2800" dirty="0"/>
+              <a:t>Penn</a:t>
+            </a:r>
+          </a:p>
+          <a:p>
+            <a:r>
+              <a:rPr lang="en-US" sz="2800" dirty="0"/>
+              <a:t>Princeton</a:t>
+            </a:r>
+          </a:p>
+          <a:p>
+            <a:r>
+              <a:rPr lang="en-US" sz="2800" dirty="0"/>
+              <a:t>Yale</a:t>
+            </a:r>
+          </a:p>
+        </p:txBody>
+      </p:sp>
+    </p:spTree>
+  </p:cSld>
+  <p:clrMapOvr>
+    <a:masterClrMapping/>
+  </p:clrMapOvr>
+</p:sld>
+</file>
+
+<file path=ppt/slides/slide36.xml><?xml version="1.0" encoding="utf-8"?>
+<p:sld xmlns:a="http://schemas.openxmlformats.org/drawingml/2006/main" xmlns:r="http://schemas.openxmlformats.org/officeDocument/2006/relationships" xmlns:p="http://schemas.openxmlformats.org/presentationml/2006/main">
+  <p:cSld>
+    <p:spTree>
+      <p:nvGrpSpPr>
+        <p:cNvPr id="1" name=""/>
+        <p:cNvGrpSpPr/>
+        <p:nvPr/>
+      </p:nvGrpSpPr>
+      <p:grpSpPr>
+        <a:xfrm>
+          <a:off x="0" y="0"/>
+          <a:ext cx="0" cy="0"/>
+          <a:chOff x="0" y="0"/>
+          <a:chExt cx="0" cy="0"/>
+        </a:xfrm>
+      </p:grpSpPr>
+      <p:sp>
+        <p:nvSpPr>
+          <p:cNvPr id="2" name="Text 2"/>
+          <p:cNvSpPr>
+            <a:spLocks noGrp="1"/>
+          </p:cNvSpPr>
+          <p:nvPr>
+            <p:ph type="body" sz="quarter" idx="21"/>
+          </p:nvPr>
+        </p:nvSpPr>
+        <p:spPr/>
+        <p:txBody>
+          <a:bodyPr/>
+          <a:lstStyle/>
+          <a:p>
+            <a:r>
+              <a:rPr lang="en-US" dirty="0"/>
+              <a:t>Red Brick founders</a:t>
+            </a:r>
+          </a:p>
+        </p:txBody>
+      </p:sp>
+      <p:sp>
+        <p:nvSpPr>
+          <p:cNvPr id="3" name="Text 3"/>
+          <p:cNvSpPr>
+            <a:spLocks noGrp="1"/>
+          </p:cNvSpPr>
+          <p:nvPr>
+            <p:ph type="body" sz="quarter" idx="22"/>
+          </p:nvPr>
+        </p:nvSpPr>
+        <p:spPr/>
+        <p:txBody>
+          <a:bodyPr/>
+          <a:lstStyle/>
+          <a:p>
+            <a:r>
+              <a:rPr lang="en-US" sz="2800" dirty="0"/>
+              <a:t>Birmingham</a:t>
+            </a:r>
+          </a:p>
+          <a:p>
+            <a:r>
+              <a:rPr lang="en-US" sz="2800" dirty="0"/>
+              <a:t>Liverpool</a:t>
+            </a:r>
+          </a:p>
+          <a:p>
+            <a:r>
+              <a:rPr lang="en-US" sz="2800" dirty="0"/>
+              <a:t>Manchester</a:t>
+            </a:r>
+          </a:p>
+        </p:txBody>
+      </p:sp>
+      <p:sp>
+        <p:nvSpPr>
+          <p:cNvPr id="4" name="Text 4"/>
+          <p:cNvSpPr>
+            <a:spLocks noGrp="1"/>
+          </p:cNvSpPr>
+          <p:nvPr>
+            <p:ph type="body" sz="quarter" idx="25"/>
+          </p:nvPr>
+        </p:nvSpPr>
+        <p:spPr/>
+        <p:txBody>
+          <a:bodyPr/>
+          <a:lstStyle/>
+          <a:p>
+            <a:r>
+              <a:rPr lang="en-US" sz="2800" dirty="0"/>
+              <a:t>Leeds</a:t>
+            </a:r>
+          </a:p>
+          <a:p>
+            <a:r>
+              <a:rPr lang="en-US" sz="2800" dirty="0"/>
+              <a:t>Sheffield</a:t>
+            </a:r>
+          </a:p>
+          <a:p>
+            <a:r>
+              <a:rPr lang="en-US" sz="2800" dirty="0"/>
+              <a:t>Bristol</a:t>
             </a:r>
           </a:p>
         </p:txBody>

</xml_diff>